<commit_message>
Phase 7: finalize pipeline, documentation and QA outputs
</commit_message>
<xml_diff>
--- a/outputs/deck/ZilaLens_Deck.pptx
+++ b/outputs/deck/ZilaLens_Deck.pptx
@@ -4520,7 +4520,7 @@
         <p:spPr>
           <a:xfrm>
             <a:off x="822960" y="3017520"/>
-            <a:ext cx="10607040" cy="3384347"/>
+            <a:ext cx="10607040" cy="3662220"/>
           </a:xfrm>
           <a:prstGeom prst="rect">
             <a:avLst/>
@@ -4530,41 +4530,6 @@
       <p:sp>
         <p:nvSpPr>
           <p:cNvPr id="5" name="TextBox 4"/>
-          <p:cNvSpPr txBox="1"/>
-          <p:nvPr/>
-        </p:nvSpPr>
-        <p:spPr>
-          <a:xfrm>
-            <a:off x="731520" y="5394960"/>
-            <a:ext cx="10698480" cy="822960"/>
-          </a:xfrm>
-          <a:prstGeom prst="rect">
-            <a:avLst/>
-          </a:prstGeom>
-          <a:noFill/>
-        </p:spPr>
-        <p:txBody>
-          <a:bodyPr wrap="none">
-            <a:spAutoFit/>
-          </a:bodyPr>
-          <a:lstStyle/>
-          <a:p>
-            <a:pPr>
-              <a:defRPr sz="1000">
-                <a:solidFill>
-                  <a:srgbClr val="5B6573"/>
-                </a:solidFill>
-              </a:defRPr>
-            </a:pPr>
-            <a:r>
-              <a:t>The theory of change states assumptions. No programme effect is claimed.</a:t>
-            </a:r>
-          </a:p>
-        </p:txBody>
-      </p:sp>
-      <p:sp>
-        <p:nvSpPr>
-          <p:cNvPr id="6" name="TextBox 5"/>
           <p:cNvSpPr txBox="1"/>
           <p:nvPr/>
         </p:nvSpPr>

</xml_diff>

<commit_message>
Phase 6: publish descriptive research deliverables
</commit_message>
<xml_diff>
--- a/outputs/deck/ZilaLens_Deck.pptx
+++ b/outputs/deck/ZilaLens_Deck.pptx
@@ -723,7 +723,7 @@
           <a:lstStyle/>
           <a:p>
             <a:r>
-              <a:t>Results remain descriptive. Aspirational District comparisons are not causal.</a:t>
+              <a:t>Validate financial access, service barriers and boundary fit before final funding decisions. Aspirational contrasts are descriptive, not causal.</a:t>
             </a:r>
           </a:p>
         </p:txBody>
@@ -793,7 +793,7 @@
           <a:lstStyle/>
           <a:p>
             <a:r>
-              <a:t>Catalog resource: “India Districts Factsheets of NFHS-5, 2019-2021”; exact destination is recorded in README and DATA_SOURCES.</a:t>
+              <a:t>555 districts per indicator; source: outputs/tables/district_changes.csv. Descriptive changes, not causal effects.</a:t>
             </a:r>
           </a:p>
         </p:txBody>
@@ -1003,7 +1003,7 @@
           <a:lstStyle/>
           <a:p>
             <a:r>
-              <a:t>Bank-account and mobile phone measures were not identified under the requested wording in the NFHS-4 compilation; exact NFHS-5 labels remain unverified.</a:t>
+              <a:t>The finance-linked index is unavailable; a separate typology uses literacy, schooling, early marriage and clean-fuel levels and changes. Source: analysis_status.md.</a:t>
             </a:r>
           </a:p>
         </p:txBody>
@@ -1073,7 +1073,7 @@
           <a:lstStyle/>
           <a:p>
             <a:r>
-              <a:t>Document the selected parent/child mapping and any assumptions before calculating change.</a:t>
+              <a:t>The appendix lacks complete parent assignments. Those entries are excluded rather than imputed. See data/processed/harvard_changed_geographies.csv.</a:t>
             </a:r>
           </a:p>
         </p:txBody>
@@ -1213,7 +1213,7 @@
           <a:lstStyle/>
           <a:p>
             <a:r>
-              <a:t>The interim UP map shows NFHS-4 baseline literacy only.</a:t>
+              <a:t>All 75 UP districts ranked in outputs/tables/up_district_rankings.csv. Ghaziabad ranks 1; Gautam Buddha Nagar ranks 6.</a:t>
             </a:r>
           </a:p>
         </p:txBody>
@@ -4784,7 +4784,7 @@
               </a:defRPr>
             </a:pPr>
             <a:r>
-              <a:t>District selection and final recommendations follow verified comparison</a:t>
+              <a:t>Five UP districts are provisional candidates for field validation</a:t>
             </a:r>
           </a:p>
         </p:txBody>
@@ -4819,7 +4819,7 @@
               </a:defRPr>
             </a:pPr>
             <a:r>
-              <a:t>Provide the official workbook, then review the crosswalk and common indicators before selecting 3–5 UP districts.</a:t>
+              <a:t>Shrawasti, Lalitpur, Bahraich, Balrampur and Sitapur rank lowest on the available four-indicator NFHS-5 composite.</a:t>
             </a:r>
           </a:p>
         </p:txBody>
@@ -4854,7 +4854,7 @@
               </a:defRPr>
             </a:pPr>
             <a:r>
-              <a:t>Results remain descriptive. Aspirational District comparisons are not causal.</a:t>
+              <a:t>Validate financial access, service barriers and boundary fit before final funding decisions. Aspirational contrasts are descriptive, not causal.</a:t>
             </a:r>
           </a:p>
         </p:txBody>
@@ -4950,7 +4950,7 @@
               </a:defRPr>
             </a:pPr>
             <a:r>
-              <a:t>NFHS-5 is the missing input for all two-round findings</a:t>
+              <a:t>Four common indicators show district-level gains</a:t>
             </a:r>
           </a:p>
         </p:txBody>
@@ -4985,7 +4985,7 @@
               </a:defRPr>
             </a:pPr>
             <a:r>
-              <a:t>The official data.gov.in workbook resource returned HTTP 403 in this environment.</a:t>
+              <a:t>Average matched changes: literacy +6.5 pp; schooling +6.3 pp; early marriage −3.8 pp; clean fuel +15.9 pp.</a:t>
             </a:r>
           </a:p>
         </p:txBody>
@@ -5020,7 +5020,7 @@
               </a:defRPr>
             </a:pPr>
             <a:r>
-              <a:t>Catalog resource: “India Districts Factsheets of NFHS-5, 2019-2021”; exact destination is recorded in README and DATA_SOURCES.</a:t>
+              <a:t>555 districts per indicator; source: outputs/tables/district_changes.csv. Descriptive changes, not causal effects.</a:t>
             </a:r>
           </a:p>
         </p:txBody>
@@ -5496,7 +5496,7 @@
               </a:defRPr>
             </a:pPr>
             <a:r>
-              <a:t>Common indicators must be confirmed from both factsheet rounds</a:t>
+              <a:t>Financial indicators are absent; a related-outcome typology is available</a:t>
             </a:r>
           </a:p>
         </p:txBody>
@@ -5531,7 +5531,7 @@
               </a:defRPr>
             </a:pPr>
             <a:r>
-              <a:t>NFHS-4 includes literacy, schooling, early marriage, clean fuel and improved sanitation indicators.</a:t>
+              <a:t>Bank-account use and women’s own mobile phone use are not available in these source files.</a:t>
             </a:r>
           </a:p>
         </p:txBody>
@@ -5566,7 +5566,7 @@
               </a:defRPr>
             </a:pPr>
             <a:r>
-              <a:t>Bank-account and mobile phone measures were not identified under the requested wording in the NFHS-4 compilation; exact NFHS-5 labels remain unverified.</a:t>
+              <a:t>The finance-linked index is unavailable; a separate typology uses literacy, schooling, early marriage and clean-fuel levels and changes. Source: analysis_status.md.</a:t>
             </a:r>
           </a:p>
         </p:txBody>
@@ -5662,7 +5662,7 @@
               </a:defRPr>
             </a:pPr>
             <a:r>
-              <a:t>Name similarity cannot resolve parent and child districts by itself</a:t>
+              <a:t>Changed geographies are screened before direct comparison</a:t>
             </a:r>
           </a:p>
         </p:txBody>
@@ -5697,7 +5697,7 @@
               </a:defRPr>
             </a:pPr>
             <a:r>
-              <a:t>Current crosswalk uses normalized names and retains fuzzy suggestions for review.</a:t>
+              <a:t>Harvard Appendix A lists 130 changed/new geography entries; 555 name-matched district IDs remain eligible.</a:t>
             </a:r>
           </a:p>
         </p:txBody>
@@ -5732,7 +5732,7 @@
               </a:defRPr>
             </a:pPr>
             <a:r>
-              <a:t>Document the selected parent/child mapping and any assumptions before calculating change.</a:t>
+              <a:t>The appendix lacks complete parent assignments. Those entries are excluded rather than imputed. See data/processed/harvard_changed_geographies.csv.</a:t>
             </a:r>
           </a:p>
         </p:txBody>
@@ -5994,7 +5994,7 @@
               </a:defRPr>
             </a:pPr>
             <a:r>
-              <a:t>UP change rankings wait for the paired NFHS-5 estimates</a:t>
+              <a:t>UP ranking flags five districts for validation</a:t>
             </a:r>
           </a:p>
         </p:txBody>
@@ -6029,7 +6029,7 @@
               </a:defRPr>
             </a:pPr>
             <a:r>
-              <a:t>Ghaziabad and Gautam Buddha Nagar can be compared with state and national benchmarks only after harmonization.</a:t>
+              <a:t>The lowest five in the NFHS-5 four-indicator mean-rank composite are Shrawasti, Lalitpur, Bahraich, Balrampur and Sitapur.</a:t>
             </a:r>
           </a:p>
         </p:txBody>
@@ -6088,7 +6088,7 @@
               </a:defRPr>
             </a:pPr>
             <a:r>
-              <a:t>The interim UP map shows NFHS-4 baseline literacy only.</a:t>
+              <a:t>All 75 UP districts ranked in outputs/tables/up_district_rankings.csv. Ghaziabad ranks 1; Gautam Buddha Nagar ranks 6.</a:t>
             </a:r>
           </a:p>
         </p:txBody>

</xml_diff>